<commit_message>
docs: add group members to submission materials
</commit_message>
<xml_diff>
--- a/deliverables/个人财务管理与可视化看板-答辩演示.pptx
+++ b/deliverables/个人财务管理与可视化看板-答辩演示.pptx
@@ -2037,45 +2037,75 @@
         </p:nvSpPr>
         <p:spPr>
           <a:xfrm>
-            <a:off x="804672" y="5257800"/>
-            <a:ext cx="6217920" cy="685800"/>
-          </a:xfrm>
-          <a:prstGeom prst="rect">
-            <a:avLst/>
-          </a:prstGeom>
-          <a:noFill/>
-          <a:ln/>
-        </p:spPr>
-        <p:txBody>
-          <a:bodyPr wrap="square" lIns="0" tIns="0" rIns="0" bIns="0" rtlCol="0" anchor="ctr"/>
-          <a:lstStyle/>
-          <a:p>
-            <a:pPr indent="0" marL="0">
-              <a:buNone/>
-            </a:pPr>
-            <a:r>
-              <a:rPr lang="en-US" sz="1200" dirty="0">
+            <a:off x="804672" y="4736592"/>
+            <a:ext cx="6537960" cy="1115568"/>
+          </a:xfrm>
+          <a:prstGeom prst="rect">
+            <a:avLst/>
+          </a:prstGeom>
+          <a:noFill/>
+          <a:ln/>
+        </p:spPr>
+        <p:txBody>
+          <a:bodyPr wrap="square" lIns="0" tIns="0" rIns="0" bIns="0" rtlCol="0" anchor="ctr">
+            <a:normAutofit/>
+          </a:bodyPr>
+          <a:lstStyle/>
+          <a:p>
+            <a:pPr indent="0" marL="0">
+              <a:buNone/>
+            </a:pPr>
+            <a:r>
+              <a:rPr lang="en-US" sz="1050" dirty="0">
                 <a:solidFill>
                   <a:srgbClr val="B9CAD5"/>
                 </a:solidFill>
               </a:rPr>
-              <a:t>姓名：【请填写】   学号：【请填写】</a:t>
-            </a:r>
-            <a:endParaRPr lang="en-US" sz="1200" dirty="0"/>
-          </a:p>
-          <a:p>
-            <a:pPr indent="0" marL="0">
-              <a:buNone/>
-            </a:pPr>
-            <a:r>
-              <a:rPr lang="en-US" sz="1200" dirty="0">
+              <a:t>小组成员</a:t>
+            </a:r>
+            <a:endParaRPr lang="en-US" sz="1050" dirty="0"/>
+          </a:p>
+          <a:p>
+            <a:pPr indent="0" marL="0">
+              <a:buNone/>
+            </a:pPr>
+            <a:r>
+              <a:rPr lang="en-US" sz="1050" dirty="0">
                 <a:solidFill>
                   <a:srgbClr val="B9CAD5"/>
                 </a:solidFill>
               </a:rPr>
+              <a:t>蓝思钰 52302042011 · 姜萱萱 52302042008 · 刘晓盼 52302042019</a:t>
+            </a:r>
+            <a:endParaRPr lang="en-US" sz="1050" dirty="0"/>
+          </a:p>
+          <a:p>
+            <a:pPr indent="0" marL="0">
+              <a:buNone/>
+            </a:pPr>
+            <a:r>
+              <a:rPr lang="en-US" sz="1050" dirty="0">
+                <a:solidFill>
+                  <a:srgbClr val="B9CAD5"/>
+                </a:solidFill>
+              </a:rPr>
+              <a:t>王晨 52302042035 · 朱婷婷 52302042055</a:t>
+            </a:r>
+            <a:endParaRPr lang="en-US" sz="1050" dirty="0"/>
+          </a:p>
+          <a:p>
+            <a:pPr indent="0" marL="0">
+              <a:buNone/>
+            </a:pPr>
+            <a:r>
+              <a:rPr lang="en-US" sz="1050" dirty="0">
+                <a:solidFill>
+                  <a:srgbClr val="B9CAD5"/>
+                </a:solidFill>
+              </a:rPr>
               <a:t>班级：【请填写】   指导教师：【请填写】</a:t>
             </a:r>
-            <a:endParaRPr lang="en-US" sz="1200" dirty="0"/>
+            <a:endParaRPr lang="en-US" sz="1050" dirty="0"/>
           </a:p>
         </p:txBody>
       </p:sp>
@@ -3444,7 +3474,7 @@
         <p:spPr>
           <a:xfrm>
             <a:off x="850392" y="5870448"/>
-            <a:ext cx="3657600" cy="228600"/>
+            <a:ext cx="5303520" cy="228600"/>
           </a:xfrm>
           <a:prstGeom prst="rect">
             <a:avLst/>
@@ -3460,14 +3490,14 @@
               <a:buNone/>
             </a:pPr>
             <a:r>
-              <a:rPr lang="en-US" sz="1000" dirty="0">
+              <a:rPr lang="en-US" sz="900" dirty="0">
                 <a:solidFill>
                   <a:srgbClr val="8EA4B5"/>
                 </a:solidFill>
               </a:rPr>
-              <a:t>【请填写姓名】 · 2026</a:t>
-            </a:r>
-            <a:endParaRPr lang="en-US" sz="1000" dirty="0"/>
+              <a:t>蓝思钰 · 姜萱萱 · 刘晓盼 · 王晨 · 朱婷婷 · 2026</a:t>
+            </a:r>
+            <a:endParaRPr lang="en-US" sz="900" dirty="0"/>
           </a:p>
         </p:txBody>
       </p:sp>

</xml_diff>